<commit_message>
hoàn thành học phần lap trình mobile
</commit_message>
<xml_diff>
--- a/lap-trinh-ung-dung-mobile/Slides/bai-01.pptx
+++ b/lap-trinh-ung-dung-mobile/Slides/bai-01.pptx
@@ -21,6 +21,7 @@
     <p:sldId id="269" r:id="rId21"/>
     <p:sldId id="270" r:id="rId22"/>
     <p:sldId id="271" r:id="rId23"/>
+    <p:sldId id="272" r:id="rId24"/>
   </p:sldIdLst>
   <p:sldSz cx="12191695" cy="6858000" type="screen4x3"/>
   <p:notesSz cx="6858000" cy="9144000"/>
@@ -733,6 +734,76 @@
           <a:p>
             <a:r>
               <a:t>Mạng phòng lab chặn kết nối: dùng `npx expo start --tunnel`.</a:t>
+            </a:r>
+          </a:p>
+        </p:txBody>
+      </p:sp>
+      <p:sp>
+        <p:nvSpPr>
+          <p:cNvPr id="4" name="Slide Number Placeholder 3"/>
+          <p:cNvSpPr>
+            <a:spLocks noGrp="1"/>
+          </p:cNvSpPr>
+          <p:nvPr>
+            <p:ph type="sldNum" idx="5" sz="quarter"/>
+          </p:nvPr>
+        </p:nvSpPr>
+        <p:spPr/>
+      </p:sp>
+    </p:spTree>
+  </p:cSld>
+  <p:clrMapOvr>
+    <a:masterClrMapping/>
+  </p:clrMapOvr>
+</p:notes>
+</file>
+
+<file path=ppt/notesSlides/notesSlide13.xml><?xml version="1.0" encoding="utf-8"?>
+<p:notes xmlns:a="http://schemas.openxmlformats.org/drawingml/2006/main" xmlns:p="http://schemas.openxmlformats.org/presentationml/2006/main" xmlns:r="http://schemas.openxmlformats.org/officeDocument/2006/relationships">
+  <p:cSld>
+    <p:spTree>
+      <p:nvGrpSpPr>
+        <p:cNvPr id="1" name=""/>
+        <p:cNvGrpSpPr/>
+        <p:nvPr/>
+      </p:nvGrpSpPr>
+      <p:grpSpPr>
+        <a:xfrm>
+          <a:off x="0" y="0"/>
+          <a:ext cx="0" cy="0"/>
+          <a:chOff x="0" y="0"/>
+          <a:chExt cx="0" cy="0"/>
+        </a:xfrm>
+      </p:grpSpPr>
+      <p:sp>
+        <p:nvSpPr>
+          <p:cNvPr id="2" name="Slide Image Placeholder 1"/>
+          <p:cNvSpPr>
+            <a:spLocks noGrp="1"/>
+          </p:cNvSpPr>
+          <p:nvPr>
+            <p:ph type="sldImg" idx="2"/>
+          </p:nvPr>
+        </p:nvSpPr>
+        <p:spPr/>
+      </p:sp>
+      <p:sp>
+        <p:nvSpPr>
+          <p:cNvPr id="3" name="Notes Placeholder 2"/>
+          <p:cNvSpPr>
+            <a:spLocks noGrp="1"/>
+          </p:cNvSpPr>
+          <p:nvPr>
+            <p:ph type="body" idx="3" sz="quarter"/>
+          </p:nvPr>
+        </p:nvSpPr>
+        <p:spPr/>
+        <p:txBody>
+          <a:bodyPr/>
+          <a:lstStyle/>
+          <a:p>
+            <a:r>
+              <a:t>Các file Word/Excel nằm ở mục Tài liệu của bài trên LMS và trang học phần (giao-trinh/, srs/, rubric/).</a:t>
             </a:r>
           </a:p>
         </p:txBody>
@@ -6987,6 +7058,317 @@
                 <a:latin typeface="Arial"/>
               </a:rPr>
               <a:t>16</a:t>
+            </a:r>
+          </a:p>
+        </p:txBody>
+      </p:sp>
+    </p:spTree>
+  </p:cSld>
+  <p:clrMapOvr>
+    <a:masterClrMapping/>
+  </p:clrMapOvr>
+</p:sld>
+</file>
+
+<file path=ppt/slides/slide17.xml><?xml version="1.0" encoding="utf-8"?>
+<p:sld xmlns:a="http://schemas.openxmlformats.org/drawingml/2006/main" xmlns:p="http://schemas.openxmlformats.org/presentationml/2006/main" xmlns:r="http://schemas.openxmlformats.org/officeDocument/2006/relationships">
+  <p:cSld>
+    <p:spTree>
+      <p:nvGrpSpPr>
+        <p:cNvPr id="1" name=""/>
+        <p:cNvGrpSpPr/>
+        <p:nvPr/>
+      </p:nvGrpSpPr>
+      <p:grpSpPr/>
+      <p:sp>
+        <p:nvSpPr>
+          <p:cNvPr id="2" name="Rectangle 1"/>
+          <p:cNvSpPr/>
+          <p:nvPr/>
+        </p:nvSpPr>
+        <p:spPr>
+          <a:xfrm>
+            <a:off x="0" y="0"/>
+            <a:ext cx="164592" cy="6858000"/>
+          </a:xfrm>
+          <a:prstGeom prst="rect">
+            <a:avLst/>
+          </a:prstGeom>
+          <a:solidFill>
+            <a:srgbClr val="013D88"/>
+          </a:solidFill>
+          <a:ln>
+            <a:noFill/>
+          </a:ln>
+          <a:effectLst/>
+        </p:spPr>
+        <p:style>
+          <a:lnRef idx="1">
+            <a:schemeClr val="accent1"/>
+          </a:lnRef>
+          <a:fillRef idx="3">
+            <a:schemeClr val="accent1"/>
+          </a:fillRef>
+          <a:effectRef idx="2">
+            <a:schemeClr val="accent1"/>
+          </a:effectRef>
+          <a:fontRef idx="minor">
+            <a:schemeClr val="lt1"/>
+          </a:fontRef>
+        </p:style>
+        <p:txBody>
+          <a:bodyPr rtlCol="0" anchor="ctr"/>
+          <a:lstStyle/>
+          <a:p>
+            <a:pPr algn="ctr"/>
+          </a:p>
+        </p:txBody>
+      </p:sp>
+      <p:sp>
+        <p:nvSpPr>
+          <p:cNvPr id="3" name="TextBox 2"/>
+          <p:cNvSpPr txBox="1"/>
+          <p:nvPr/>
+        </p:nvSpPr>
+        <p:spPr>
+          <a:xfrm>
+            <a:off x="548640" y="320040"/>
+            <a:ext cx="11155680" cy="822960"/>
+          </a:xfrm>
+          <a:prstGeom prst="rect">
+            <a:avLst/>
+          </a:prstGeom>
+          <a:noFill/>
+        </p:spPr>
+        <p:txBody>
+          <a:bodyPr wrap="square">
+            <a:spAutoFit/>
+          </a:bodyPr>
+          <a:lstStyle/>
+          <a:p>
+            <a:r>
+              <a:rPr b="1" sz="3000">
+                <a:solidFill>
+                  <a:srgbClr val="013D88"/>
+                </a:solidFill>
+                <a:latin typeface="Arial"/>
+              </a:rPr>
+              <a:t>Tài liệu của buổi</a:t>
+            </a:r>
+          </a:p>
+        </p:txBody>
+      </p:sp>
+      <p:sp>
+        <p:nvSpPr>
+          <p:cNvPr id="4" name="Rectangle 3"/>
+          <p:cNvSpPr/>
+          <p:nvPr/>
+        </p:nvSpPr>
+        <p:spPr>
+          <a:xfrm>
+            <a:off x="548640" y="1097280"/>
+            <a:ext cx="1097280" cy="54864"/>
+          </a:xfrm>
+          <a:prstGeom prst="rect">
+            <a:avLst/>
+          </a:prstGeom>
+          <a:solidFill>
+            <a:srgbClr val="FFC627"/>
+          </a:solidFill>
+          <a:ln>
+            <a:noFill/>
+          </a:ln>
+          <a:effectLst/>
+        </p:spPr>
+        <p:style>
+          <a:lnRef idx="1">
+            <a:schemeClr val="accent1"/>
+          </a:lnRef>
+          <a:fillRef idx="3">
+            <a:schemeClr val="accent1"/>
+          </a:fillRef>
+          <a:effectRef idx="2">
+            <a:schemeClr val="accent1"/>
+          </a:effectRef>
+          <a:fontRef idx="minor">
+            <a:schemeClr val="lt1"/>
+          </a:fontRef>
+        </p:style>
+        <p:txBody>
+          <a:bodyPr rtlCol="0" anchor="ctr"/>
+          <a:lstStyle/>
+          <a:p>
+            <a:pPr algn="ctr"/>
+          </a:p>
+        </p:txBody>
+      </p:sp>
+      <p:sp>
+        <p:nvSpPr>
+          <p:cNvPr id="5" name="TextBox 4"/>
+          <p:cNvSpPr txBox="1"/>
+          <p:nvPr/>
+        </p:nvSpPr>
+        <p:spPr>
+          <a:xfrm>
+            <a:off x="548640" y="1371600"/>
+            <a:ext cx="11064240" cy="4754880"/>
+          </a:xfrm>
+          <a:prstGeom prst="rect">
+            <a:avLst/>
+          </a:prstGeom>
+          <a:noFill/>
+        </p:spPr>
+        <p:txBody>
+          <a:bodyPr wrap="square">
+            <a:spAutoFit/>
+          </a:bodyPr>
+          <a:lstStyle/>
+          <a:p>
+            <a:pPr>
+              <a:spcBef>
+                <a:spcPts val="300"/>
+              </a:spcBef>
+            </a:pPr>
+            <a:r>
+              <a:rPr b="1" sz="2000">
+                <a:solidFill>
+                  <a:srgbClr val="01295C"/>
+                </a:solidFill>
+                <a:latin typeface="Arial"/>
+              </a:rPr>
+              <a:t>Đọc thêm</a:t>
+            </a:r>
+          </a:p>
+          <a:p>
+            <a:pPr>
+              <a:spcBef>
+                <a:spcPts val="300"/>
+              </a:spcBef>
+            </a:pPr>
+            <a:r>
+              <a:rPr b="0" sz="2000">
+                <a:solidFill>
+                  <a:srgbClr val="212529"/>
+                </a:solidFill>
+                <a:latin typeface="Arial"/>
+              </a:rPr>
+              <a:t>•  Giáo trình nội bộ, Chương 1: Tổng quan phát triển ứng dụng di động và khởi động dự án</a:t>
+            </a:r>
+          </a:p>
+          <a:p>
+            <a:pPr>
+              <a:spcBef>
+                <a:spcPts val="300"/>
+              </a:spcBef>
+            </a:pPr>
+            <a:r>
+              <a:rPr b="0" sz="2000">
+                <a:solidFill>
+                  <a:srgbClr val="212529"/>
+                </a:solidFill>
+                <a:latin typeface="Arial"/>
+              </a:rPr>
+              <a:t>•  Bài tập hướng dẫn theo dự án LHU Food (cuối Chương 1)</a:t>
+            </a:r>
+          </a:p>
+          <a:p>
+            <a:pPr>
+              <a:spcBef>
+                <a:spcPts val="300"/>
+              </a:spcBef>
+            </a:pPr>
+            <a:r>
+              <a:rPr b="0" sz="2000">
+                <a:solidFill>
+                  <a:srgbClr val="212529"/>
+                </a:solidFill>
+                <a:latin typeface="Arial"/>
+              </a:rPr>
+              <a:t>•  SRS LHU Food: mục 2 (mô tả), 3 (actor), 5.14 (màn hình)</a:t>
+            </a:r>
+          </a:p>
+          <a:p>
+            <a:pPr>
+              <a:spcBef>
+                <a:spcPts val="300"/>
+              </a:spcBef>
+            </a:pPr>
+            <a:r>
+              <a:rPr b="0" sz="2000">
+                <a:solidFill>
+                  <a:srgbClr val="212529"/>
+                </a:solidFill>
+                <a:latin typeface="Arial"/>
+              </a:rPr>
+              <a:t>•  Kế hoạch Agile &amp; Product Backlog (Definition of Done, tiêu chí nghiệm thu)</a:t>
+            </a:r>
+          </a:p>
+        </p:txBody>
+      </p:sp>
+      <p:sp>
+        <p:nvSpPr>
+          <p:cNvPr id="6" name="TextBox 5"/>
+          <p:cNvSpPr txBox="1"/>
+          <p:nvPr/>
+        </p:nvSpPr>
+        <p:spPr>
+          <a:xfrm>
+            <a:off x="548640" y="6355080"/>
+            <a:ext cx="9144000" cy="320040"/>
+          </a:xfrm>
+          <a:prstGeom prst="rect">
+            <a:avLst/>
+          </a:prstGeom>
+          <a:noFill/>
+        </p:spPr>
+        <p:txBody>
+          <a:bodyPr wrap="square">
+            <a:spAutoFit/>
+          </a:bodyPr>
+          <a:lstStyle/>
+          <a:p>
+            <a:r>
+              <a:rPr b="0" sz="1100">
+                <a:solidFill>
+                  <a:srgbClr val="6C757D"/>
+                </a:solidFill>
+                <a:latin typeface="Arial"/>
+              </a:rPr>
+              <a:t>Lập trình ứng dụng di động (111114) • Bài 01: Tổng quan phát triển ứng dụng di động &amp; khởi động dự án</a:t>
+            </a:r>
+          </a:p>
+        </p:txBody>
+      </p:sp>
+      <p:sp>
+        <p:nvSpPr>
+          <p:cNvPr id="7" name="TextBox 6"/>
+          <p:cNvSpPr txBox="1"/>
+          <p:nvPr/>
+        </p:nvSpPr>
+        <p:spPr>
+          <a:xfrm>
+            <a:off x="10972800" y="6355080"/>
+            <a:ext cx="731520" cy="320040"/>
+          </a:xfrm>
+          <a:prstGeom prst="rect">
+            <a:avLst/>
+          </a:prstGeom>
+          <a:noFill/>
+        </p:spPr>
+        <p:txBody>
+          <a:bodyPr wrap="square">
+            <a:spAutoFit/>
+          </a:bodyPr>
+          <a:lstStyle/>
+          <a:p>
+            <a:r>
+              <a:rPr b="0" sz="1100">
+                <a:solidFill>
+                  <a:srgbClr val="6C757D"/>
+                </a:solidFill>
+                <a:latin typeface="Arial"/>
+              </a:rPr>
+              <a:t>17</a:t>
             </a:r>
           </a:p>
         </p:txBody>

</xml_diff>